<commit_message>
feat: render VECTOR columns as PCA scatter charts
Oracle AI Database stores embeddings, but the only way to look at one was
the query preview, which summarizes it as <VECTOR(n)>. create_chart now
accepts a vector type that projects the first VECTOR column to two
dimensions with PCA and plots it, so embeddings can be explored without
leaving SQL.

Dense (array.array) and sparse vectors both convert; the first non-vector
column labels the points, and each axis names the variance its component
explains. The added schema costs 18 tokens, so the benchmark results,
figures, paper, deck, and site were regenerated to match.

💘 Generated with Crush

Assisted-by: Crush:deepseek-v4.1-flash
</commit_message>
<xml_diff>
--- a/slides/oraviz-results-deck.pptx
+++ b/slides/oraviz-results-deck.pptx
@@ -3937,7 +3937,7 @@
                   <a:srgbClr val="C74634"/>
                 </a:solidFill>
               </a:rPr>
-              <a:t>844</a:t>
+              <a:t>862</a:t>
             </a:r>
           </a:p>
           <a:p>
@@ -3948,7 +3948,7 @@
                   <a:srgbClr val="6B6B6B"/>
                 </a:solidFill>
               </a:rPr>
-              <a:t>tokens of tool schemas — OraViz (60.5% fewer)</a:t>
+              <a:t>tokens of tool schemas — OraViz (59.7% fewer)</a:t>
             </a:r>
           </a:p>
         </p:txBody>
@@ -5989,7 +5989,7 @@
                   <a:srgbClr val="C74634"/>
                 </a:solidFill>
               </a:rPr>
-              <a:t>-60.5%</a:t>
+              <a:t>-59.7%</a:t>
             </a:r>
           </a:p>
           <a:p>
@@ -6000,7 +6000,7 @@
                   <a:srgbClr val="6B6B6B"/>
                 </a:solidFill>
               </a:rPr>
-              <a:t>tool schemas (844 vs 2,139)</a:t>
+              <a:t>tool schemas (862 vs 2,139)</a:t>
             </a:r>
           </a:p>
         </p:txBody>
@@ -6051,7 +6051,7 @@
                   <a:srgbClr val="C74634"/>
                 </a:solidFill>
               </a:rPr>
-              <a:t>-53.7%</a:t>
+              <a:t>-53.3%</a:t>
             </a:r>
           </a:p>
           <a:p>
@@ -6062,7 +6062,7 @@
                   <a:srgbClr val="6B6B6B"/>
                 </a:solidFill>
               </a:rPr>
-              <a:t>tool results (2,319 vs 5,004)</a:t>
+              <a:t>tool results (2,337 vs 5,004)</a:t>
             </a:r>
           </a:p>
         </p:txBody>
@@ -6113,7 +6113,7 @@
                   <a:srgbClr val="C74634"/>
                 </a:solidFill>
               </a:rPr>
-              <a:t>-53.7%</a:t>
+              <a:t>-53.3%</a:t>
             </a:r>
           </a:p>
           <a:p>
@@ -6124,7 +6124,7 @@
                   <a:srgbClr val="6B6B6B"/>
                 </a:solidFill>
               </a:rPr>
-              <a:t>total (2,319 vs 5,006)</a:t>
+              <a:t>total (2,337 vs 5,006)</a:t>
             </a:r>
           </a:p>
         </p:txBody>
@@ -6182,7 +6182,7 @@
                   <a:srgbClr val="6B6B6B"/>
                 </a:solidFill>
               </a:rPr>
-              <a:t>o200k_base agrees within one point (53.6% total savings).</a:t>
+              <a:t>o200k_base agrees within one point (53.2% total savings).</a:t>
             </a:r>
           </a:p>
         </p:txBody>

</xml_diff>